<commit_message>
Slides: new title, Julius Meinl company slides with logo and photo, Assessment strategy divider
Co-Authored-By: Claude Sonnet 5.5 <noreply@anthropic.com>
Claude-Session: https://claude.ai/code/session_01RkWScMhuRmEB4zppSmB7Ri
</commit_message>
<xml_diff>
--- a/WT26-27/Business Projects WT26-27 Slides.pptx
+++ b/WT26-27/Business Projects WT26-27 Slides.pptx
@@ -16,6 +16,8 @@
     <p:sldId id="314" r:id="rId40"/>
     <p:sldId id="318" r:id="rId44"/>
     <p:sldId id="303" r:id="rId12"/>
+    <p:sldId id="329" r:id="rId55"/>
+    <p:sldId id="330" r:id="rId56"/>
     <p:sldId id="315" r:id="rId41"/>
     <p:sldId id="316" r:id="rId42"/>
     <p:sldId id="324" r:id="rId50"/>
@@ -24,7 +26,6 @@
     <p:sldId id="317" r:id="rId43"/>
     <p:sldId id="319" r:id="rId45"/>
     <p:sldId id="325" r:id="rId51"/>
-    <p:sldId id="327" r:id="rId53"/>
     <p:sldId id="320" r:id="rId46"/>
     <p:sldId id="328" r:id="rId54"/>
     <p:sldId id="326" r:id="rId52"/>
@@ -8123,7 +8124,7 @@
             <a:pPr lvl="0"/>
             <a:r>
               <a:rPr lang="en-GB" dirty="0"/>
-              <a:t>Business Projects</a:t>
+              <a:t>International Business Projects</a:t>
             </a:r>
           </a:p>
         </p:txBody>
@@ -8161,22 +8162,45 @@
             <p:ph type="body" sz="quarter" idx="11"/>
           </p:nvPr>
         </p:nvSpPr>
-        <p:spPr/>
+        <p:spPr>
+          <a:xfrm>
+            <a:off x="287338" y="2941638"/>
+            <a:ext cx="4284662" cy="1250000"/>
+          </a:xfrm>
+        </p:spPr>
         <p:txBody>
           <a:bodyPr/>
           <a:lstStyle/>
           <a:p>
             <a:pPr lvl="0"/>
             <a:r>
-              <a:rPr lang="en-GB" dirty="0"/>
+              <a:rPr lang="en-GB" dirty="0" sz="1100"/>
               <a:t>Dr Arne Floh, Senior Lecturer in Marketing</a:t>
             </a:r>
           </a:p>
           <a:p>
             <a:pPr lvl="0"/>
             <a:r>
-              <a:rPr lang="en-GB" dirty="0"/>
+              <a:rPr lang="en-GB" dirty="0" sz="1100"/>
               <a:t>WU Vienna, Institute for International Business</a:t>
+            </a:r>
+          </a:p>
+          <a:p>
+            <a:pPr lvl="0"/>
+            <a:r>
+              <a:rPr lang="en-GB" dirty="0" sz="1100">
+                <a:hlinkClick r:id="rId20"/>
+              </a:rPr>
+              <a:t>arne.floh@wu.ac.at</a:t>
+            </a:r>
+          </a:p>
+          <a:p>
+            <a:pPr lvl="0"/>
+            <a:r>
+              <a:rPr lang="en-GB" dirty="0" sz="1100">
+                <a:hlinkClick r:id="rId21"/>
+              </a:rPr>
+              <a:t>Office hours: book online (Google Calendar)</a:t>
             </a:r>
           </a:p>
         </p:txBody>
@@ -8802,36 +8826,34 @@
           <a:p>
             <a:pPr lvl="0"/>
             <a:r>
-              <a:rPr lang="en-GB" dirty="0" sz="1600"/>
-              <a:t>Family-owned Viennese coffee roaster, founded in 1862, now in its fifth generation</a:t>
-            </a:r>
-          </a:p>
-          <a:p>
-            <a:pPr lvl="0"/>
-            <a:r>
-              <a:rPr lang="en-GB" dirty="0" sz="1600"/>
-              <a:t>Present in more than 70 countries, mostly through local distribution partners</a:t>
-            </a:r>
-          </a:p>
-          <a:p>
-            <a:pPr lvl="0"/>
-            <a:r>
-              <a:rPr lang="en-GB" dirty="0" sz="1600"/>
-              <a:t>Customers in hospitality (HoReCa: cafés, restaurants, hotels) and in grocery retail</a:t>
-            </a:r>
-          </a:p>
-          <a:p>
-            <a:pPr lvl="0"/>
-            <a:r>
-              <a:rPr lang="en-GB" dirty="0" sz="1600"/>
-              <a:t>No own sales organisation in export markets</a:t>
-            </a:r>
-          </a:p>
-          <a:p>
-            <a:pPr lvl="0"/>
-            <a:r>
-              <a:rPr lang="en-GB" dirty="0" sz="1600"/>
-              <a:t>Success depends heavily on the local partner and on how well the brand is positioned in the market</a:t>
+              <a:rPr lang="en-GB" dirty="0" sz="1500" b="1"/>
+              <a:t>Hospitality: </a:t>
+            </a:r>
+            <a:r>
+              <a:rPr lang="en-GB" dirty="0" sz="1500"/>
+              <a:t>hotels with breakfast and bar service, especially with international guests; premium restaurants and cafés; venues where coffee is part of a quality experience</a:t>
+            </a:r>
+          </a:p>
+          <a:p>
+            <a:pPr lvl="0"/>
+            <a:r>
+              <a:rPr lang="en-GB" dirty="0" sz="1500" b="1"/>
+              <a:t>Retail: </a:t>
+            </a:r>
+            <a:r>
+              <a:rPr lang="en-GB" dirty="0" sz="1500"/>
+              <a:t>grocery and delicatessen with a premium assortment; shoppers who can pay a premium price; places where brands such as illy are already on the shelf</a:t>
+            </a:r>
+          </a:p>
+          <a:p>
+            <a:pPr lvl="0"/>
+            <a:r>
+              <a:rPr lang="en-GB" dirty="0" sz="1500" b="1"/>
+              <a:t>Less relevant: </a:t>
+            </a:r>
+            <a:r>
+              <a:rPr lang="en-GB" dirty="0" sz="1500"/>
+              <a:t>venues and retailers competing on price, and areas without purchasing power</a:t>
             </a:r>
           </a:p>
         </p:txBody>
@@ -8906,7 +8928,7 @@
             <a:pPr lvl="0"/>
             <a:r>
               <a:rPr lang="en-GB" dirty="0"/>
-              <a:t>Our partner: Julius Meinl</a:t>
+              <a:t>Who Julius Meinl sells to</a:t>
             </a:r>
           </a:p>
         </p:txBody>
@@ -10271,7 +10293,7 @@
             <a:pPr lvl="0"/>
             <a:r>
               <a:rPr lang="en-GB" dirty="0"/>
-              <a:t>Three group presentations</a:t>
+              <a:t>Assessment strategy</a:t>
             </a:r>
           </a:p>
         </p:txBody>
@@ -10299,7 +10321,7 @@
             <a:pPr lvl="0"/>
             <a:r>
               <a:rPr lang="en-GB" dirty="0"/>
-              <a:t>Content, midterm and final presentation</a:t>
+              <a:t>Three group presentations, self-reflection and peer review</a:t>
             </a:r>
           </a:p>
         </p:txBody>
@@ -11299,141 +11321,6 @@
     <p:extLst>
       <p:ext uri="{BB962C8B-B14F-4D97-AF65-F5344CB8AC3E}">
         <p14:creationId xmlns:p14="http://schemas.microsoft.com/office/powerpoint/2010/main" val="2309806499"/>
-      </p:ext>
-    </p:extLst>
-  </p:cSld>
-  <p:clrMapOvr>
-    <a:masterClrMapping/>
-  </p:clrMapOvr>
-  <p:transition>
-    <p:fade/>
-  </p:transition>
-</p:sld>
-</file>
-
-<file path=ppt/slides/slide41.xml><?xml version="1.0" encoding="utf-8"?>
-<p:sld xmlns:a="http://schemas.openxmlformats.org/drawingml/2006/main" xmlns:r="http://schemas.openxmlformats.org/officeDocument/2006/relationships" xmlns:p="http://schemas.openxmlformats.org/presentationml/2006/main">
-  <p:cSld>
-    <p:spTree>
-      <p:nvGrpSpPr>
-        <p:cNvPr id="1" name=""/>
-        <p:cNvGrpSpPr/>
-        <p:nvPr/>
-      </p:nvGrpSpPr>
-      <p:grpSpPr>
-        <a:xfrm>
-          <a:off x="0" y="0"/>
-          <a:ext cx="0" cy="0"/>
-          <a:chOff x="0" y="0"/>
-          <a:chExt cx="0" cy="0"/>
-        </a:xfrm>
-      </p:grpSpPr>
-      <p:sp>
-        <p:nvSpPr>
-          <p:cNvPr id="2" name="Titel 1"/>
-          <p:cNvSpPr>
-            <a:spLocks noGrp="1"/>
-          </p:cNvSpPr>
-          <p:nvPr>
-            <p:ph type="ctrTitle"/>
-          </p:nvPr>
-        </p:nvSpPr>
-        <p:spPr/>
-        <p:txBody>
-          <a:bodyPr/>
-          <a:lstStyle/>
-          <a:p>
-            <a:pPr lvl="0"/>
-            <a:r>
-              <a:rPr lang="en-GB" dirty="0"/>
-              <a:t>Assessment and organisation</a:t>
-            </a:r>
-          </a:p>
-        </p:txBody>
-      </p:sp>
-      <p:sp>
-        <p:nvSpPr>
-          <p:cNvPr id="3" name="Textplatzhalter 2"/>
-          <p:cNvSpPr>
-            <a:spLocks noGrp="1"/>
-          </p:cNvSpPr>
-          <p:nvPr>
-            <p:ph type="body" sz="quarter" idx="11"/>
-          </p:nvPr>
-        </p:nvSpPr>
-        <p:spPr>
-          <a:xfrm>
-            <a:off x="287338" y="2642907"/>
-            <a:ext cx="4284662" cy="805551"/>
-          </a:xfrm>
-        </p:spPr>
-        <p:txBody>
-          <a:bodyPr/>
-          <a:lstStyle/>
-          <a:p>
-            <a:pPr lvl="0"/>
-            <a:r>
-              <a:rPr lang="en-GB" dirty="0"/>
-              <a:t>Grading, schedule and rules</a:t>
-            </a:r>
-          </a:p>
-        </p:txBody>
-      </p:sp>
-      <p:sp>
-        <p:nvSpPr>
-          <p:cNvPr id="4" name="Footer Placeholder 3"/>
-          <p:cNvSpPr>
-            <a:spLocks noGrp="1"/>
-          </p:cNvSpPr>
-          <p:nvPr>
-            <p:ph type="ftr" sz="quarter" idx="13"/>
-          </p:nvPr>
-        </p:nvSpPr>
-        <p:spPr/>
-        <p:txBody>
-          <a:bodyPr/>
-          <a:lstStyle/>
-          <a:p>
-            <a:r>
-              <a:rPr lang="en-GB"/>
-              <a:t>Business Projects WT 2026/27 | Julius Meinl</a:t>
-            </a:r>
-            <a:endParaRPr lang="en-GB" dirty="0"/>
-          </a:p>
-        </p:txBody>
-      </p:sp>
-      <p:sp>
-        <p:nvSpPr>
-          <p:cNvPr id="5" name="Slide Number Placeholder 4"/>
-          <p:cNvSpPr>
-            <a:spLocks noGrp="1"/>
-          </p:cNvSpPr>
-          <p:nvPr>
-            <p:ph type="sldNum" sz="quarter" idx="14"/>
-          </p:nvPr>
-        </p:nvSpPr>
-        <p:spPr/>
-        <p:txBody>
-          <a:bodyPr/>
-          <a:lstStyle/>
-          <a:p>
-            <a:r>
-              <a:rPr lang="en-GB"/>
-              <a:t>Page </a:t>
-            </a:r>
-            <a:fld id="{BE3DC40E-DBBE-4E2D-9EEC-FBF0DA0E9179}" type="slidenum">
-              <a:rPr lang="en-GB" smtClean="0"/>
-              <a:pPr/>
-              <a:t>8</a:t>
-            </a:fld>
-            <a:endParaRPr lang="en-GB" dirty="0"/>
-          </a:p>
-        </p:txBody>
-      </p:sp>
-    </p:spTree>
-    <p:extLst>
-      <p:ext uri="{BB962C8B-B14F-4D97-AF65-F5344CB8AC3E}">
-        <p14:creationId xmlns:p14="http://schemas.microsoft.com/office/powerpoint/2010/main" val="83271545"/>
       </p:ext>
     </p:extLst>
   </p:cSld>
@@ -11942,6 +11829,449 @@
     <p:extLst>
       <p:ext uri="{BB962C8B-B14F-4D97-AF65-F5344CB8AC3E}">
         <p14:creationId xmlns:p14="http://schemas.microsoft.com/office/powerpoint/2010/main" val="3543249116"/>
+      </p:ext>
+    </p:extLst>
+  </p:cSld>
+  <p:clrMapOvr>
+    <a:masterClrMapping/>
+  </p:clrMapOvr>
+  <p:transition>
+    <p:fade/>
+  </p:transition>
+</p:sld>
+</file>
+
+<file path=ppt/slides/slide43.xml><?xml version="1.0" encoding="utf-8"?>
+<p:sld xmlns:a="http://schemas.openxmlformats.org/drawingml/2006/main" xmlns:r="http://schemas.openxmlformats.org/officeDocument/2006/relationships" xmlns:p="http://schemas.openxmlformats.org/presentationml/2006/main">
+  <p:cSld>
+    <p:spTree>
+      <p:nvGrpSpPr>
+        <p:cNvPr id="1" name=""/>
+        <p:cNvGrpSpPr/>
+        <p:nvPr/>
+      </p:nvGrpSpPr>
+      <p:grpSpPr>
+        <a:xfrm>
+          <a:off x="0" y="0"/>
+          <a:ext cx="0" cy="0"/>
+          <a:chOff x="0" y="0"/>
+          <a:chExt cx="0" cy="0"/>
+        </a:xfrm>
+      </p:grpSpPr>
+      <p:sp>
+        <p:nvSpPr>
+          <p:cNvPr id="10" name="Inhaltsplatzhalter 9"/>
+          <p:cNvSpPr>
+            <a:spLocks noGrp="1"/>
+          </p:cNvSpPr>
+          <p:nvPr>
+            <p:ph sz="half" idx="1"/>
+          </p:nvPr>
+        </p:nvSpPr>
+        <p:spPr/>
+        <p:txBody>
+          <a:bodyPr>
+            <a:normAutofit/>
+          </a:bodyPr>
+          <a:lstStyle/>
+          <a:p>
+            <a:pPr lvl="0"/>
+            <a:r>
+              <a:rPr lang="en-GB" dirty="0" sz="1400" b="1"/>
+              <a:t>1862: </a:t>
+            </a:r>
+            <a:r>
+              <a:rPr lang="en-GB" dirty="0" sz="1400"/>
+              <a:t>family-owned Viennese coffee roaster, now in its fifth generation</a:t>
+            </a:r>
+          </a:p>
+          <a:p>
+            <a:pPr lvl="0"/>
+            <a:r>
+              <a:rPr lang="en-GB" dirty="0" sz="1400" b="1"/>
+              <a:t>70+ countries: </a:t>
+            </a:r>
+            <a:r>
+              <a:rPr lang="en-GB" dirty="0" sz="1400"/>
+              <a:t>mostly through local distribution partners</a:t>
+            </a:r>
+          </a:p>
+          <a:p>
+            <a:pPr lvl="0"/>
+            <a:r>
+              <a:rPr lang="en-GB" dirty="0" sz="1400" b="1"/>
+              <a:t>2 segments per market: </a:t>
+            </a:r>
+            <a:r>
+              <a:rPr lang="en-GB" dirty="0" sz="1400"/>
+              <a:t>hospitality and grocery retail</a:t>
+            </a:r>
+          </a:p>
+          <a:p>
+            <a:pPr lvl="0"/>
+            <a:r>
+              <a:rPr lang="en-GB" dirty="0" sz="1400" b="1"/>
+              <a:t>Positioning: </a:t>
+            </a:r>
+            <a:r>
+              <a:rPr lang="en-GB" dirty="0" sz="1400"/>
+              <a:t>Viennese coffee house culture rather than the bean itself, meaning service, hospitality and the idea of taking time for a cup of coffee</a:t>
+            </a:r>
+          </a:p>
+        </p:txBody>
+      </p:sp>
+      <p:sp>
+        <p:nvSpPr>
+          <p:cNvPr id="5" name="Fußzeilenplatzhalter 4"/>
+          <p:cNvSpPr>
+            <a:spLocks noGrp="1"/>
+          </p:cNvSpPr>
+          <p:nvPr>
+            <p:ph type="ftr" sz="quarter" idx="11"/>
+          </p:nvPr>
+        </p:nvSpPr>
+        <p:spPr/>
+        <p:txBody>
+          <a:bodyPr/>
+          <a:lstStyle/>
+          <a:p>
+            <a:r>
+              <a:rPr lang="en-GB" dirty="0"/>
+              <a:t>Business Projects WT 2026/27 | Julius Meinl</a:t>
+            </a:r>
+          </a:p>
+        </p:txBody>
+      </p:sp>
+      <p:sp>
+        <p:nvSpPr>
+          <p:cNvPr id="6" name="Foliennummernplatzhalter 5"/>
+          <p:cNvSpPr>
+            <a:spLocks noGrp="1"/>
+          </p:cNvSpPr>
+          <p:nvPr>
+            <p:ph type="sldNum" sz="quarter" idx="12"/>
+          </p:nvPr>
+        </p:nvSpPr>
+        <p:spPr/>
+        <p:txBody>
+          <a:bodyPr/>
+          <a:lstStyle/>
+          <a:p>
+            <a:r>
+              <a:rPr lang="en-GB" dirty="0"/>
+              <a:t>Page </a:t>
+            </a:r>
+            <a:fld id="{941D2295-CC7E-4B5B-BFD3-593FD9D32866}" type="slidenum">
+              <a:rPr lang="en-GB" smtClean="0"/>
+              <a:pPr/>
+              <a:t>17</a:t>
+            </a:fld>
+            <a:endParaRPr lang="en-GB" dirty="0"/>
+          </a:p>
+        </p:txBody>
+      </p:sp>
+      <p:sp>
+        <p:nvSpPr>
+          <p:cNvPr id="9" name="Titel 8"/>
+          <p:cNvSpPr>
+            <a:spLocks noGrp="1"/>
+          </p:cNvSpPr>
+          <p:nvPr>
+            <p:ph type="title"/>
+          </p:nvPr>
+        </p:nvSpPr>
+        <p:spPr/>
+        <p:txBody>
+          <a:bodyPr/>
+          <a:lstStyle/>
+          <a:p>
+            <a:pPr lvl="0"/>
+            <a:r>
+              <a:rPr lang="en-GB" dirty="0"/>
+              <a:t>Our partner: Julius Meinl</a:t>
+            </a:r>
+          </a:p>
+        </p:txBody>
+      </p:sp>
+      <p:pic>
+        <p:nvPicPr>
+          <p:cNvPr id="101" name="Julius Meinl espresso cups" descr="Two red Julius Meinl espresso cups on an espresso machine"/>
+          <p:cNvPicPr>
+            <a:picLocks noChangeAspect="1"/>
+          </p:cNvPicPr>
+          <p:nvPr/>
+        </p:nvPicPr>
+        <p:blipFill>
+          <a:blip r:embed="rId100"/>
+          <a:srcRect t="15000" b="21200"/>
+          <a:stretch>
+            <a:fillRect/>
+          </a:stretch>
+        </p:blipFill>
+        <p:spPr>
+          <a:xfrm>
+            <a:off x="4715688" y="1344613"/>
+            <a:ext cx="3960000" cy="3859212"/>
+          </a:xfrm>
+          <a:prstGeom prst="rect">
+            <a:avLst/>
+          </a:prstGeom>
+        </p:spPr>
+      </p:pic>
+      <p:pic>
+        <p:nvPicPr>
+          <p:cNvPr id="102" name="Julius Meinl logo" descr="Julius Meinl logo, Vienna 1862"/>
+          <p:cNvPicPr>
+            <a:picLocks noChangeAspect="1"/>
+          </p:cNvPicPr>
+          <p:nvPr/>
+        </p:nvPicPr>
+        <p:blipFill>
+          <a:blip r:embed="rId101"/>
+          <a:stretch>
+            <a:fillRect/>
+          </a:stretch>
+        </p:blipFill>
+        <p:spPr>
+          <a:xfrm>
+            <a:off x="7715688" y="4243825"/>
+            <a:ext cx="860000" cy="860000"/>
+          </a:xfrm>
+          <a:prstGeom prst="rect">
+            <a:avLst/>
+          </a:prstGeom>
+        </p:spPr>
+      </p:pic>
+    </p:spTree>
+    <p:extLst>
+      <p:ext uri="{BB962C8B-B14F-4D97-AF65-F5344CB8AC3E}">
+        <p14:creationId xmlns:p14="http://schemas.microsoft.com/office/powerpoint/2010/main" val="3852802689"/>
+      </p:ext>
+    </p:extLst>
+  </p:cSld>
+  <p:clrMapOvr>
+    <a:masterClrMapping/>
+  </p:clrMapOvr>
+  <p:transition>
+    <p:fade/>
+  </p:transition>
+</p:sld>
+</file>
+
+<file path=ppt/slides/slide44.xml><?xml version="1.0" encoding="utf-8"?>
+<p:sld xmlns:a="http://schemas.openxmlformats.org/drawingml/2006/main" xmlns:r="http://schemas.openxmlformats.org/officeDocument/2006/relationships" xmlns:p="http://schemas.openxmlformats.org/presentationml/2006/main">
+  <p:cSld>
+    <p:spTree>
+      <p:nvGrpSpPr>
+        <p:cNvPr id="1" name=""/>
+        <p:cNvGrpSpPr/>
+        <p:nvPr/>
+      </p:nvGrpSpPr>
+      <p:grpSpPr>
+        <a:xfrm>
+          <a:off x="0" y="0"/>
+          <a:ext cx="0" cy="0"/>
+          <a:chOff x="0" y="0"/>
+          <a:chExt cx="0" cy="0"/>
+        </a:xfrm>
+      </p:grpSpPr>
+      <p:sp>
+        <p:nvSpPr>
+          <p:cNvPr id="7" name="Inhaltsplatzhalter 6"/>
+          <p:cNvSpPr>
+            <a:spLocks noGrp="1"/>
+          </p:cNvSpPr>
+          <p:nvPr>
+            <p:ph sz="half" idx="1"/>
+          </p:nvPr>
+        </p:nvSpPr>
+        <p:spPr/>
+        <p:txBody>
+          <a:bodyPr/>
+          <a:lstStyle/>
+          <a:p>
+            <a:pPr lvl="0"/>
+            <a:r>
+              <a:rPr lang="en-GB" dirty="0" sz="1400"/>
+              <a:t>Cafés, restaurants and hotels</a:t>
+            </a:r>
+          </a:p>
+          <a:p>
+            <a:pPr lvl="0"/>
+            <a:r>
+              <a:rPr lang="en-GB" dirty="0" sz="1400"/>
+              <a:t>The primary segment: hotels matter most, with breakfast and bar business</a:t>
+            </a:r>
+          </a:p>
+          <a:p>
+            <a:pPr lvl="0"/>
+            <a:r>
+              <a:rPr lang="en-GB" dirty="0" sz="1400"/>
+              <a:t>A dedicated partner, because hotels and grocery chains are different businesses</a:t>
+            </a:r>
+          </a:p>
+        </p:txBody>
+      </p:sp>
+      <p:sp>
+        <p:nvSpPr>
+          <p:cNvPr id="8" name="Inhaltsplatzhalter 7"/>
+          <p:cNvSpPr>
+            <a:spLocks noGrp="1"/>
+          </p:cNvSpPr>
+          <p:nvPr>
+            <p:ph sz="half" idx="2"/>
+          </p:nvPr>
+        </p:nvSpPr>
+        <p:spPr/>
+        <p:txBody>
+          <a:bodyPr/>
+          <a:lstStyle/>
+          <a:p>
+            <a:pPr lvl="0"/>
+            <a:r>
+              <a:rPr lang="en-GB" dirty="0" sz="1400"/>
+              <a:t>Coffee for the home, through grocery chains and delicatessen</a:t>
+            </a:r>
+          </a:p>
+          <a:p>
+            <a:pPr lvl="0"/>
+            <a:r>
+              <a:rPr lang="en-GB" dirty="0" sz="1400"/>
+              <a:t>Premium assortment</a:t>
+            </a:r>
+          </a:p>
+          <a:p>
+            <a:pPr lvl="0"/>
+            <a:r>
+              <a:rPr lang="en-GB" dirty="0" sz="1400"/>
+              <a:t>A dedicated partner: with no own sales organisation in export markets, the partner is the sales force</a:t>
+            </a:r>
+          </a:p>
+        </p:txBody>
+      </p:sp>
+      <p:sp>
+        <p:nvSpPr>
+          <p:cNvPr id="4" name="Textplatzhalter 3"/>
+          <p:cNvSpPr>
+            <a:spLocks noGrp="1"/>
+          </p:cNvSpPr>
+          <p:nvPr>
+            <p:ph type="body" idx="13"/>
+          </p:nvPr>
+        </p:nvSpPr>
+        <p:spPr/>
+        <p:txBody>
+          <a:bodyPr/>
+          <a:lstStyle/>
+          <a:p>
+            <a:pPr lvl="0"/>
+            <a:r>
+              <a:rPr lang="en-GB" dirty="0"/>
+              <a:t>Hospitality (HoReCa)</a:t>
+            </a:r>
+          </a:p>
+        </p:txBody>
+      </p:sp>
+      <p:sp>
+        <p:nvSpPr>
+          <p:cNvPr id="5" name="Fußzeilenplatzhalter 4"/>
+          <p:cNvSpPr>
+            <a:spLocks noGrp="1"/>
+          </p:cNvSpPr>
+          <p:nvPr>
+            <p:ph type="ftr" sz="quarter" idx="15"/>
+          </p:nvPr>
+        </p:nvSpPr>
+        <p:spPr/>
+        <p:txBody>
+          <a:bodyPr/>
+          <a:lstStyle/>
+          <a:p>
+            <a:r>
+              <a:rPr lang="en-GB" dirty="0"/>
+              <a:t>Business Projects WT 2026/27 | Julius Meinl</a:t>
+            </a:r>
+          </a:p>
+        </p:txBody>
+      </p:sp>
+      <p:sp>
+        <p:nvSpPr>
+          <p:cNvPr id="6" name="Foliennummernplatzhalter 5"/>
+          <p:cNvSpPr>
+            <a:spLocks noGrp="1"/>
+          </p:cNvSpPr>
+          <p:nvPr>
+            <p:ph type="sldNum" sz="quarter" idx="16"/>
+          </p:nvPr>
+        </p:nvSpPr>
+        <p:spPr/>
+        <p:txBody>
+          <a:bodyPr/>
+          <a:lstStyle/>
+          <a:p>
+            <a:r>
+              <a:rPr lang="en-GB" dirty="0"/>
+              <a:t>Page </a:t>
+            </a:r>
+            <a:fld id="{941D2295-CC7E-4B5B-BFD3-593FD9D32866}" type="slidenum">
+              <a:rPr lang="en-GB" smtClean="0"/>
+              <a:pPr/>
+              <a:t>18</a:t>
+            </a:fld>
+            <a:endParaRPr lang="en-GB" dirty="0"/>
+          </a:p>
+        </p:txBody>
+      </p:sp>
+      <p:sp>
+        <p:nvSpPr>
+          <p:cNvPr id="9" name="Titel 8"/>
+          <p:cNvSpPr>
+            <a:spLocks noGrp="1"/>
+          </p:cNvSpPr>
+          <p:nvPr>
+            <p:ph type="title"/>
+          </p:nvPr>
+        </p:nvSpPr>
+        <p:spPr/>
+        <p:txBody>
+          <a:bodyPr/>
+          <a:lstStyle/>
+          <a:p>
+            <a:pPr lvl="0"/>
+            <a:r>
+              <a:rPr lang="en-GB" dirty="0"/>
+              <a:t>How Julius Meinl sells: two segments, two partners</a:t>
+            </a:r>
+          </a:p>
+        </p:txBody>
+      </p:sp>
+      <p:sp>
+        <p:nvSpPr>
+          <p:cNvPr id="3" name="Textplatzhalter 2"/>
+          <p:cNvSpPr>
+            <a:spLocks noGrp="1"/>
+          </p:cNvSpPr>
+          <p:nvPr>
+            <p:ph type="body" sz="quarter" idx="17"/>
+          </p:nvPr>
+        </p:nvSpPr>
+        <p:spPr/>
+        <p:txBody>
+          <a:bodyPr/>
+          <a:lstStyle/>
+          <a:p>
+            <a:pPr lvl="0"/>
+            <a:r>
+              <a:rPr lang="en-GB" dirty="0"/>
+              <a:t>Grocery retail</a:t>
+            </a:r>
+          </a:p>
+        </p:txBody>
+      </p:sp>
+    </p:spTree>
+    <p:extLst>
+      <p:ext uri="{BB962C8B-B14F-4D97-AF65-F5344CB8AC3E}">
+        <p14:creationId xmlns:p14="http://schemas.microsoft.com/office/powerpoint/2010/main" val="490384932"/>
       </p:ext>
     </p:extLst>
   </p:cSld>

</xml_diff>

<commit_message>
Slides: title and contact slides use the new Titelfolie Kontakt and Abschlussfolie Kontakt layouts
Co-Authored-By: Claude Sonnet 5.5 <noreply@anthropic.com>
Claude-Session: https://claude.ai/code/session_01RkWScMhuRmEB4zppSmB7Ri
</commit_message>
<xml_diff>
--- a/WT26-27/Business Projects WT26-27 Slides.pptx
+++ b/WT26-27/Business Projects WT26-27 Slides.pptx
@@ -3534,6 +3534,911 @@
               <a:ea typeface="+mn-ea"/>
               <a:cs typeface="+mn-cs"/>
             </a:endParaRPr>
+          </a:p>
+        </p:txBody>
+      </p:sp>
+      <p:sp>
+        <p:nvSpPr>
+          <p:cNvPr id="8" name="Datumsplatzhalter 7"/>
+          <p:cNvSpPr>
+            <a:spLocks noGrp="1"/>
+          </p:cNvSpPr>
+          <p:nvPr>
+            <p:ph type="dt" sz="half" idx="11"/>
+          </p:nvPr>
+        </p:nvSpPr>
+        <p:spPr/>
+        <p:txBody>
+          <a:bodyPr/>
+          <a:lstStyle/>
+          <a:p>
+            <a:fld id="{D1DA7DE9-F6B6-4FDA-A00F-1221D494593B}" type="datetime1">
+              <a:rPr lang="en-GB" smtClean="0"/>
+              <a:t>25/08/2023</a:t>
+            </a:fld>
+            <a:endParaRPr lang="en-GB" dirty="0"/>
+          </a:p>
+        </p:txBody>
+      </p:sp>
+      <p:sp>
+        <p:nvSpPr>
+          <p:cNvPr id="9" name="Fußzeilenplatzhalter 8"/>
+          <p:cNvSpPr>
+            <a:spLocks noGrp="1"/>
+          </p:cNvSpPr>
+          <p:nvPr>
+            <p:ph type="ftr" sz="quarter" idx="12"/>
+          </p:nvPr>
+        </p:nvSpPr>
+        <p:spPr/>
+        <p:txBody>
+          <a:bodyPr/>
+          <a:lstStyle/>
+          <a:p>
+            <a:r>
+              <a:rPr lang="en-GB" dirty="0"/>
+              <a:t>Sample Footer</a:t>
+            </a:r>
+          </a:p>
+        </p:txBody>
+      </p:sp>
+      <p:sp>
+        <p:nvSpPr>
+          <p:cNvPr id="10" name="Foliennummernplatzhalter 9"/>
+          <p:cNvSpPr>
+            <a:spLocks noGrp="1"/>
+          </p:cNvSpPr>
+          <p:nvPr>
+            <p:ph type="sldNum" sz="quarter" idx="13"/>
+          </p:nvPr>
+        </p:nvSpPr>
+        <p:spPr/>
+        <p:txBody>
+          <a:bodyPr/>
+          <a:lstStyle/>
+          <a:p>
+            <a:r>
+              <a:rPr lang="en-GB" dirty="0"/>
+              <a:t>Page </a:t>
+            </a:r>
+            <a:fld id="{BE3DC40E-DBBE-4E2D-9EEC-FBF0DA0E9179}" type="slidenum">
+              <a:rPr lang="en-GB" smtClean="0"/>
+              <a:t>‹Nr.›</a:t>
+            </a:fld>
+            <a:endParaRPr lang="en-GB" dirty="0"/>
+          </a:p>
+        </p:txBody>
+      </p:sp>
+    </p:spTree>
+  </p:cSld>
+  <p:clrMapOvr>
+    <a:masterClrMapping/>
+  </p:clrMapOvr>
+  <p:transition>
+    <p:fade/>
+  </p:transition>
+</p:sldLayout>
+</file>
+
+<file path=ppt/slideLayouts/slideLayout16.xml><?xml version="1.0" encoding="utf-8"?>
+<p:sldLayout xmlns:a="http://schemas.openxmlformats.org/drawingml/2006/main" xmlns:r="http://schemas.openxmlformats.org/officeDocument/2006/relationships" xmlns:p="http://schemas.openxmlformats.org/presentationml/2006/main" showMasterSp="0" preserve="1" userDrawn="1">
+  <p:cSld name="Titelfolie Kontakt">
+    <p:bg>
+      <p:bgPr>
+        <a:blipFill dpi="0" rotWithShape="1">
+          <a:blip r:embed="rId2">
+            <a:lum/>
+          </a:blip>
+          <a:srcRect/>
+          <a:stretch>
+            <a:fillRect/>
+          </a:stretch>
+        </a:blipFill>
+        <a:effectLst/>
+      </p:bgPr>
+    </p:bg>
+    <p:spTree>
+      <p:nvGrpSpPr>
+        <p:cNvPr id="1" name=""/>
+        <p:cNvGrpSpPr/>
+        <p:nvPr/>
+      </p:nvGrpSpPr>
+      <p:grpSpPr>
+        <a:xfrm>
+          <a:off x="0" y="0"/>
+          <a:ext cx="0" cy="0"/>
+          <a:chOff x="0" y="0"/>
+          <a:chExt cx="0" cy="0"/>
+        </a:xfrm>
+      </p:grpSpPr>
+      <p:grpSp>
+        <p:nvGrpSpPr>
+          <p:cNvPr id="11" name="Gruppieren 10"/>
+          <p:cNvGrpSpPr/>
+          <p:nvPr userDrawn="1"/>
+        </p:nvGrpSpPr>
+        <p:grpSpPr>
+          <a:xfrm>
+            <a:off x="287338" y="603319"/>
+            <a:ext cx="8552850" cy="2037600"/>
+            <a:chOff x="287338" y="603319"/>
+            <a:chExt cx="8552850" cy="2037600"/>
+          </a:xfrm>
+        </p:grpSpPr>
+        <p:sp>
+          <p:nvSpPr>
+            <p:cNvPr id="14" name="Rechteck 13"/>
+            <p:cNvSpPr/>
+            <p:nvPr userDrawn="1"/>
+          </p:nvSpPr>
+          <p:spPr>
+            <a:xfrm>
+              <a:off x="6192000" y="603319"/>
+              <a:ext cx="2648188" cy="2037600"/>
+            </a:xfrm>
+            <a:prstGeom prst="rect">
+              <a:avLst/>
+            </a:prstGeom>
+            <a:solidFill>
+              <a:schemeClr val="bg1"/>
+            </a:solidFill>
+            <a:ln>
+              <a:noFill/>
+            </a:ln>
+          </p:spPr>
+          <p:style>
+            <a:lnRef idx="3">
+              <a:schemeClr val="lt1"/>
+            </a:lnRef>
+            <a:fillRef idx="1">
+              <a:schemeClr val="accent1"/>
+            </a:fillRef>
+            <a:effectRef idx="1">
+              <a:schemeClr val="accent1"/>
+            </a:effectRef>
+            <a:fontRef idx="minor">
+              <a:schemeClr val="lt1"/>
+            </a:fontRef>
+          </p:style>
+          <p:txBody>
+            <a:bodyPr rtlCol="0" anchor="ctr"/>
+            <a:lstStyle/>
+            <a:p>
+              <a:pPr algn="ctr"/>
+              <a:endParaRPr lang="en-GB" dirty="0"/>
+            </a:p>
+          </p:txBody>
+        </p:sp>
+        <p:sp>
+          <p:nvSpPr>
+            <p:cNvPr id="15" name="Rechteck 14"/>
+            <p:cNvSpPr/>
+            <p:nvPr userDrawn="1"/>
+          </p:nvSpPr>
+          <p:spPr bwMode="blackWhite">
+            <a:xfrm>
+              <a:off x="287338" y="603319"/>
+              <a:ext cx="5904662" cy="2037600"/>
+            </a:xfrm>
+            <a:prstGeom prst="rect">
+              <a:avLst/>
+            </a:prstGeom>
+            <a:solidFill>
+              <a:srgbClr val="0096D3">
+                <a:alpha val="89804"/>
+              </a:srgbClr>
+            </a:solidFill>
+            <a:ln>
+              <a:noFill/>
+            </a:ln>
+          </p:spPr>
+          <p:style>
+            <a:lnRef idx="3">
+              <a:schemeClr val="lt1"/>
+            </a:lnRef>
+            <a:fillRef idx="1">
+              <a:schemeClr val="accent1"/>
+            </a:fillRef>
+            <a:effectRef idx="1">
+              <a:schemeClr val="accent1"/>
+            </a:effectRef>
+            <a:fontRef idx="minor">
+              <a:schemeClr val="lt1"/>
+            </a:fontRef>
+          </p:style>
+          <p:txBody>
+            <a:bodyPr rtlCol="0" anchor="ctr"/>
+            <a:lstStyle/>
+            <a:p>
+              <a:pPr algn="ctr"/>
+              <a:endParaRPr lang="en-GB" dirty="0"/>
+            </a:p>
+          </p:txBody>
+        </p:sp>
+      </p:grpSp>
+      <p:sp>
+        <p:nvSpPr>
+          <p:cNvPr id="2" name="Titel 1"/>
+          <p:cNvSpPr>
+            <a:spLocks noGrp="1"/>
+          </p:cNvSpPr>
+          <p:nvPr userDrawn="1">
+            <p:ph type="ctrTitle" hasCustomPrompt="1"/>
+          </p:nvPr>
+        </p:nvSpPr>
+        <p:spPr bwMode="black">
+          <a:xfrm>
+            <a:off x="605406" y="1301365"/>
+            <a:ext cx="5436000" cy="1026000"/>
+          </a:xfrm>
+          <a:prstGeom prst="rect">
+            <a:avLst/>
+          </a:prstGeom>
+        </p:spPr>
+        <p:txBody>
+          <a:bodyPr tIns="0" anchor="ctr" anchorCtr="0">
+            <a:noAutofit/>
+          </a:bodyPr>
+          <a:lstStyle>
+            <a:lvl1pPr algn="l">
+              <a:lnSpc>
+                <a:spcPct val="100000"/>
+              </a:lnSpc>
+              <a:defRPr sz="3200" b="1" i="0" baseline="0">
+                <a:solidFill>
+                  <a:schemeClr val="bg1"/>
+                </a:solidFill>
+                <a:latin typeface="Georgia" charset="0"/>
+                <a:ea typeface="Georgia" charset="0"/>
+                <a:cs typeface="Georgia" charset="0"/>
+              </a:defRPr>
+            </a:lvl1pPr>
+          </a:lstStyle>
+          <a:p>
+            <a:r>
+              <a:rPr lang="en-GB" dirty="0"/>
+              <a:t>Max. 2 lines of text for header</a:t>
+            </a:r>
+          </a:p>
+        </p:txBody>
+      </p:sp>
+      <p:sp>
+        <p:nvSpPr>
+          <p:cNvPr id="3" name="Untertitel 2"/>
+          <p:cNvSpPr>
+            <a:spLocks noGrp="1"/>
+          </p:cNvSpPr>
+          <p:nvPr userDrawn="1">
+            <p:ph type="subTitle" idx="1" hasCustomPrompt="1"/>
+          </p:nvPr>
+        </p:nvSpPr>
+        <p:spPr bwMode="black">
+          <a:xfrm>
+            <a:off x="605406" y="993080"/>
+            <a:ext cx="5436000" cy="351533"/>
+          </a:xfrm>
+        </p:spPr>
+        <p:txBody>
+          <a:bodyPr tIns="0" bIns="0">
+            <a:noAutofit/>
+          </a:bodyPr>
+          <a:lstStyle>
+            <a:lvl1pPr marL="0" indent="0" algn="l">
+              <a:lnSpc>
+                <a:spcPct val="100000"/>
+              </a:lnSpc>
+              <a:buNone/>
+              <a:defRPr sz="1800" b="1" i="0" baseline="0">
+                <a:solidFill>
+                  <a:schemeClr val="tx1"/>
+                </a:solidFill>
+                <a:latin typeface="Verdana" charset="0"/>
+                <a:ea typeface="Verdana" charset="0"/>
+                <a:cs typeface="Verdana" charset="0"/>
+              </a:defRPr>
+            </a:lvl1pPr>
+            <a:lvl2pPr marL="457153" indent="0" algn="ctr">
+              <a:buNone/>
+              <a:defRPr>
+                <a:solidFill>
+                  <a:schemeClr val="tx1">
+                    <a:tint val="75000"/>
+                  </a:schemeClr>
+                </a:solidFill>
+              </a:defRPr>
+            </a:lvl2pPr>
+            <a:lvl3pPr marL="914306" indent="0" algn="ctr">
+              <a:buNone/>
+              <a:defRPr>
+                <a:solidFill>
+                  <a:schemeClr val="tx1">
+                    <a:tint val="75000"/>
+                  </a:schemeClr>
+                </a:solidFill>
+              </a:defRPr>
+            </a:lvl3pPr>
+            <a:lvl4pPr marL="1371460" indent="0" algn="ctr">
+              <a:buNone/>
+              <a:defRPr>
+                <a:solidFill>
+                  <a:schemeClr val="tx1">
+                    <a:tint val="75000"/>
+                  </a:schemeClr>
+                </a:solidFill>
+              </a:defRPr>
+            </a:lvl4pPr>
+            <a:lvl5pPr marL="1828613" indent="0" algn="ctr">
+              <a:buNone/>
+              <a:defRPr>
+                <a:solidFill>
+                  <a:schemeClr val="tx1">
+                    <a:tint val="75000"/>
+                  </a:schemeClr>
+                </a:solidFill>
+              </a:defRPr>
+            </a:lvl5pPr>
+            <a:lvl6pPr marL="2285767" indent="0" algn="ctr">
+              <a:buNone/>
+              <a:defRPr>
+                <a:solidFill>
+                  <a:schemeClr val="tx1">
+                    <a:tint val="75000"/>
+                  </a:schemeClr>
+                </a:solidFill>
+              </a:defRPr>
+            </a:lvl6pPr>
+            <a:lvl7pPr marL="2742920" indent="0" algn="ctr">
+              <a:buNone/>
+              <a:defRPr>
+                <a:solidFill>
+                  <a:schemeClr val="tx1">
+                    <a:tint val="75000"/>
+                  </a:schemeClr>
+                </a:solidFill>
+              </a:defRPr>
+            </a:lvl7pPr>
+            <a:lvl8pPr marL="3200073" indent="0" algn="ctr">
+              <a:buNone/>
+              <a:defRPr>
+                <a:solidFill>
+                  <a:schemeClr val="tx1">
+                    <a:tint val="75000"/>
+                  </a:schemeClr>
+                </a:solidFill>
+              </a:defRPr>
+            </a:lvl8pPr>
+            <a:lvl9pPr marL="3657227" indent="0" algn="ctr">
+              <a:buNone/>
+              <a:defRPr>
+                <a:solidFill>
+                  <a:schemeClr val="tx1">
+                    <a:tint val="75000"/>
+                  </a:schemeClr>
+                </a:solidFill>
+              </a:defRPr>
+            </a:lvl9pPr>
+          </a:lstStyle>
+          <a:p>
+            <a:r>
+              <a:rPr lang="en-GB" dirty="0"/>
+              <a:t>Add subtitle here if required</a:t>
+            </a:r>
+          </a:p>
+        </p:txBody>
+      </p:sp>
+      <p:sp>
+        <p:nvSpPr>
+          <p:cNvPr id="10" name="Kontaktdaten"/>
+          <p:cNvSpPr>
+            <a:spLocks noGrp="1"/>
+          </p:cNvSpPr>
+          <p:nvPr userDrawn="1"/>
+        </p:nvSpPr>
+        <p:spPr bwMode="white">
+          <a:xfrm>
+            <a:off x="287338" y="2941638"/>
+            <a:ext cx="4284662" cy="1400000"/>
+          </a:xfrm>
+          <a:prstGeom prst="rect">
+            <a:avLst/>
+          </a:prstGeom>
+          <a:solidFill>
+            <a:srgbClr val="FFFFFF">
+              <a:alpha val="90000"/>
+            </a:srgbClr>
+          </a:solidFill>
+          <a:ln>
+            <a:noFill/>
+          </a:ln>
+        </p:spPr>
+        <p:txBody>
+          <a:bodyPr wrap="square" lIns="324000" tIns="216000" rIns="324000" bIns="216000" rtlCol="0" anchor="t" anchorCtr="0">
+            <a:spAutoFit/>
+          </a:bodyPr>
+          <a:lstStyle>
+            <a:lvl1pPr marL="0" indent="0">
+              <a:buNone/>
+              <a:defRPr lang="de-DE" sz="1200" baseline="0" dirty="0" smtClean="0"/>
+            </a:lvl1pPr>
+          </a:lstStyle>
+          <a:p>
+            <a:pPr marL="0" indent="0">
+              <a:buNone/>
+            </a:pPr>
+            <a:r>
+              <a:rPr lang="en-GB" sz="1100" dirty="0">
+                <a:solidFill>
+                  <a:srgbClr val="000000"/>
+                </a:solidFill>
+                <a:latin typeface="+mn-lt"/>
+              </a:rPr>
+              <a:t>Dr Arne Floh, Senior Lecturer in Marketing</a:t>
+            </a:r>
+          </a:p>
+          <a:p>
+            <a:pPr marL="0" indent="0">
+              <a:buNone/>
+            </a:pPr>
+            <a:r>
+              <a:rPr lang="en-GB" sz="1100" dirty="0">
+                <a:solidFill>
+                  <a:srgbClr val="000000"/>
+                </a:solidFill>
+                <a:latin typeface="+mn-lt"/>
+              </a:rPr>
+              <a:t>WU Vienna, Institute for International Business</a:t>
+            </a:r>
+          </a:p>
+          <a:p>
+            <a:pPr marL="0" indent="0">
+              <a:buNone/>
+            </a:pPr>
+            <a:r>
+              <a:rPr lang="en-GB" sz="1100" dirty="0">
+                <a:solidFill>
+                  <a:srgbClr val="000000"/>
+                </a:solidFill>
+                <a:latin typeface="+mn-lt"/>
+                <a:hlinkClick r:id="rId20"/>
+              </a:rPr>
+              <a:t>arne.floh@wu.ac.at</a:t>
+            </a:r>
+          </a:p>
+          <a:p>
+            <a:pPr marL="0" indent="0">
+              <a:buNone/>
+            </a:pPr>
+            <a:r>
+              <a:rPr lang="en-GB" sz="1100" dirty="0">
+                <a:solidFill>
+                  <a:srgbClr val="000000"/>
+                </a:solidFill>
+                <a:latin typeface="+mn-lt"/>
+                <a:hlinkClick r:id="rId21"/>
+              </a:rPr>
+              <a:t>Office hours: book online (Google Calendar)</a:t>
+            </a:r>
+          </a:p>
+        </p:txBody>
+      </p:sp>
+      <p:sp>
+        <p:nvSpPr>
+          <p:cNvPr id="12" name="Textplatzhalter 7"/>
+          <p:cNvSpPr>
+            <a:spLocks noGrp="1"/>
+          </p:cNvSpPr>
+          <p:nvPr>
+            <p:ph type="body" sz="quarter" idx="12" hasCustomPrompt="1"/>
+          </p:nvPr>
+        </p:nvSpPr>
+        <p:spPr bwMode="auto">
+          <a:xfrm>
+            <a:off x="457200" y="5426926"/>
+            <a:ext cx="1638300" cy="243623"/>
+          </a:xfrm>
+        </p:spPr>
+        <p:txBody>
+          <a:bodyPr>
+            <a:noAutofit/>
+          </a:bodyPr>
+          <a:lstStyle>
+            <a:lvl1pPr marL="0" indent="0">
+              <a:buNone/>
+              <a:defRPr sz="900" cap="all" baseline="0">
+                <a:solidFill>
+                  <a:schemeClr val="bg1"/>
+                </a:solidFill>
+              </a:defRPr>
+            </a:lvl1pPr>
+            <a:lvl2pPr marL="266700" indent="0">
+              <a:buNone/>
+              <a:defRPr sz="1050"/>
+            </a:lvl2pPr>
+            <a:lvl3pPr marL="541338" indent="0">
+              <a:buNone/>
+              <a:defRPr sz="1050"/>
+            </a:lvl3pPr>
+            <a:lvl4pPr marL="808038" indent="0">
+              <a:buNone/>
+              <a:defRPr sz="1000"/>
+            </a:lvl4pPr>
+            <a:lvl5pPr marL="1077913" indent="0">
+              <a:buNone/>
+              <a:defRPr sz="1000"/>
+            </a:lvl5pPr>
+          </a:lstStyle>
+          <a:p>
+            <a:pPr lvl="0"/>
+            <a:r>
+              <a:rPr lang="en-GB" dirty="0"/>
+              <a:t>State: </a:t>
+            </a:r>
+            <a:r>
+              <a:rPr lang="en-GB" dirty="0" err="1"/>
+              <a:t>xx.xx.xxxx</a:t>
+            </a:r>
+            <a:endParaRPr lang="en-GB" dirty="0"/>
+          </a:p>
+        </p:txBody>
+      </p:sp>
+      <p:pic>
+        <p:nvPicPr>
+          <p:cNvPr id="18" name="Grafik 17">
+            <a:extLst>
+              <a:ext uri="{FF2B5EF4-FFF2-40B4-BE49-F238E27FC236}">
+                <a16:creationId xmlns:a16="http://schemas.microsoft.com/office/drawing/2014/main" id="{35A845CD-2D10-42BB-97DB-CDA723EE9EBF}"/>
+              </a:ext>
+            </a:extLst>
+          </p:cNvPr>
+          <p:cNvPicPr>
+            <a:picLocks noChangeAspect="1"/>
+          </p:cNvPicPr>
+          <p:nvPr userDrawn="1"/>
+        </p:nvPicPr>
+        <p:blipFill>
+          <a:blip r:embed="rId3"/>
+          <a:stretch>
+            <a:fillRect/>
+          </a:stretch>
+        </p:blipFill>
+        <p:spPr>
+          <a:xfrm>
+            <a:off x="6579375" y="1065910"/>
+            <a:ext cx="1849165" cy="975600"/>
+          </a:xfrm>
+          <a:prstGeom prst="rect">
+            <a:avLst/>
+          </a:prstGeom>
+        </p:spPr>
+      </p:pic>
+      <p:pic>
+        <p:nvPicPr>
+          <p:cNvPr id="16" name="Grafik 15">
+            <a:extLst>
+              <a:ext uri="{FF2B5EF4-FFF2-40B4-BE49-F238E27FC236}">
+                <a16:creationId xmlns:a16="http://schemas.microsoft.com/office/drawing/2014/main" id="{1A49BD17-4238-4565-A4B6-2E20A7C19FA6}"/>
+              </a:ext>
+            </a:extLst>
+          </p:cNvPr>
+          <p:cNvPicPr>
+            <a:picLocks noChangeAspect="1"/>
+          </p:cNvPicPr>
+          <p:nvPr userDrawn="1"/>
+        </p:nvPicPr>
+        <p:blipFill>
+          <a:blip r:embed="rId4">
+            <a:extLst>
+              <a:ext uri="{28A0092B-C50C-407E-A947-70E740481C1C}">
+                <a14:useLocalDpi xmlns:a14="http://schemas.microsoft.com/office/drawing/2010/main" val="0"/>
+              </a:ext>
+            </a:extLst>
+          </a:blip>
+          <a:stretch>
+            <a:fillRect/>
+          </a:stretch>
+        </p:blipFill>
+        <p:spPr>
+          <a:xfrm>
+            <a:off x="6615113" y="5129960"/>
+            <a:ext cx="1835942" cy="317581"/>
+          </a:xfrm>
+          <a:prstGeom prst="rect">
+            <a:avLst/>
+          </a:prstGeom>
+        </p:spPr>
+      </p:pic>
+    </p:spTree>
+    <p:extLst>
+      <p:ext uri="{BB962C8B-B14F-4D97-AF65-F5344CB8AC3E}">
+        <p14:creationId xmlns:p14="http://schemas.microsoft.com/office/powerpoint/2010/main" val="1096689772"/>
+      </p:ext>
+    </p:extLst>
+  </p:cSld>
+  <p:clrMapOvr>
+    <a:masterClrMapping/>
+  </p:clrMapOvr>
+  <p:transition>
+    <p:fade/>
+  </p:transition>
+  <p:extLst>
+    <p:ext uri="{DCECCB84-F9BA-43D5-87BE-67443E8EF086}">
+      <p15:sldGuideLst xmlns:p15="http://schemas.microsoft.com/office/powerpoint/2012/main"/>
+    </p:ext>
+  </p:extLst>
+</p:sldLayout>
+</file>
+
+<file path=ppt/slideLayouts/slideLayout19.xml><?xml version="1.0" encoding="utf-8"?>
+<p:sldLayout xmlns:a="http://schemas.openxmlformats.org/drawingml/2006/main" xmlns:r="http://schemas.openxmlformats.org/officeDocument/2006/relationships" xmlns:p="http://schemas.openxmlformats.org/presentationml/2006/main" preserve="1" userDrawn="1">
+  <p:cSld name="Abschlussfolie Kontakt">
+    <p:spTree>
+      <p:nvGrpSpPr>
+        <p:cNvPr id="1" name=""/>
+        <p:cNvGrpSpPr/>
+        <p:nvPr/>
+      </p:nvGrpSpPr>
+      <p:grpSpPr>
+        <a:xfrm>
+          <a:off x="0" y="0"/>
+          <a:ext cx="0" cy="0"/>
+          <a:chOff x="0" y="0"/>
+          <a:chExt cx="0" cy="0"/>
+        </a:xfrm>
+      </p:grpSpPr>
+      <p:sp>
+        <p:nvSpPr>
+          <p:cNvPr id="5" name="Rechteck 4"/>
+          <p:cNvSpPr/>
+          <p:nvPr/>
+        </p:nvSpPr>
+        <p:spPr>
+          <a:xfrm>
+            <a:off x="467544" y="1964530"/>
+            <a:ext cx="4319712" cy="2716954"/>
+          </a:xfrm>
+          <a:prstGeom prst="rect">
+            <a:avLst/>
+          </a:prstGeom>
+          <a:ln w="12700">
+            <a:solidFill>
+              <a:schemeClr val="bg1">
+                <a:lumMod val="50000"/>
+              </a:schemeClr>
+            </a:solidFill>
+          </a:ln>
+          <a:effectLst/>
+        </p:spPr>
+        <p:style>
+          <a:lnRef idx="2">
+            <a:schemeClr val="dk1"/>
+          </a:lnRef>
+          <a:fillRef idx="1">
+            <a:schemeClr val="lt1"/>
+          </a:fillRef>
+          <a:effectRef idx="0">
+            <a:schemeClr val="dk1"/>
+          </a:effectRef>
+          <a:fontRef idx="minor">
+            <a:schemeClr val="dk1"/>
+          </a:fontRef>
+        </p:style>
+        <p:txBody>
+          <a:bodyPr lIns="91431" tIns="45715" rIns="91431" bIns="45715" rtlCol="0" anchor="ctr"/>
+          <a:lstStyle/>
+          <a:p>
+            <a:pPr algn="ctr"/>
+            <a:endParaRPr lang="en-GB" dirty="0"/>
+          </a:p>
+        </p:txBody>
+      </p:sp>
+      <p:pic>
+        <p:nvPicPr>
+          <p:cNvPr id="7" name="Grafik 6" descr="Logo-für-VK.png"/>
+          <p:cNvPicPr>
+            <a:picLocks noChangeAspect="1"/>
+          </p:cNvPicPr>
+          <p:nvPr/>
+        </p:nvPicPr>
+        <p:blipFill>
+          <a:blip r:embed="rId2" cstate="print"/>
+          <a:stretch>
+            <a:fillRect/>
+          </a:stretch>
+        </p:blipFill>
+        <p:spPr>
+          <a:xfrm>
+            <a:off x="611560" y="2127250"/>
+            <a:ext cx="492443" cy="2252663"/>
+          </a:xfrm>
+          <a:prstGeom prst="rect">
+            <a:avLst/>
+          </a:prstGeom>
+        </p:spPr>
+      </p:pic>
+      <p:sp>
+        <p:nvSpPr>
+          <p:cNvPr id="11" name="Kontaktdaten"/>
+          <p:cNvSpPr>
+            <a:spLocks noGrp="1"/>
+          </p:cNvSpPr>
+          <p:nvPr userDrawn="1"/>
+        </p:nvSpPr>
+        <p:spPr>
+          <a:xfrm>
+            <a:off x="1684020" y="2559843"/>
+            <a:ext cx="2763926" cy="1811291"/>
+          </a:xfrm>
+          <a:prstGeom prst="rect">
+            <a:avLst/>
+          </a:prstGeom>
+        </p:spPr>
+        <p:txBody>
+          <a:bodyPr>
+            <a:normAutofit/>
+          </a:bodyPr>
+          <a:lstStyle>
+            <a:lvl1pPr marL="0" marR="0" indent="0" algn="l" defTabSz="914306" rtl="0" eaLnBrk="1" fontAlgn="auto" latinLnBrk="0" hangingPunct="1">
+              <a:lnSpc>
+                <a:spcPct val="100000"/>
+              </a:lnSpc>
+              <a:spcBef>
+                <a:spcPts val="0"/>
+              </a:spcBef>
+              <a:spcAft>
+                <a:spcPts val="0"/>
+              </a:spcAft>
+              <a:buClr>
+                <a:srgbClr val="4B2582"/>
+              </a:buClr>
+              <a:buSzTx/>
+              <a:buFont typeface="Wingdings" pitchFamily="2" charset="2"/>
+              <a:buNone/>
+              <a:tabLst/>
+              <a:defRPr sz="1100" baseline="0"/>
+            </a:lvl1pPr>
+            <a:lvl2pPr marL="0" indent="0">
+              <a:buNone/>
+              <a:defRPr/>
+            </a:lvl2pPr>
+            <a:lvl3pPr marL="0" indent="0">
+              <a:buNone/>
+              <a:defRPr/>
+            </a:lvl3pPr>
+            <a:lvl4pPr marL="0" indent="0">
+              <a:buNone/>
+              <a:defRPr/>
+            </a:lvl4pPr>
+            <a:lvl5pPr marL="0" indent="0">
+              <a:buNone/>
+              <a:defRPr/>
+            </a:lvl5pPr>
+          </a:lstStyle>
+          <a:p>
+            <a:pPr marL="0" indent="0">
+              <a:buNone/>
+            </a:pPr>
+            <a:r>
+              <a:rPr lang="en-GB" sz="1000" b="1" dirty="0">
+                <a:solidFill>
+                  <a:srgbClr val="000000"/>
+                </a:solidFill>
+                <a:latin typeface="+mn-lt"/>
+              </a:rPr>
+              <a:t>INSTITUTE FOR INTERNATIONAL BUSINESS</a:t>
+            </a:r>
+          </a:p>
+          <a:p>
+            <a:pPr marL="0" indent="0">
+              <a:buNone/>
+            </a:pPr>
+            <a:r>
+              <a:rPr lang="en-GB" sz="1000" dirty="0">
+                <a:solidFill>
+                  <a:srgbClr val="000000"/>
+                </a:solidFill>
+                <a:latin typeface="+mn-lt"/>
+              </a:rPr>
+              <a:t>Welthandelsplatz 1, 1020 Vienna, Austria</a:t>
+            </a:r>
+          </a:p>
+          <a:p>
+            <a:pPr marL="0" indent="0">
+              <a:buNone/>
+            </a:pPr>
+            <a:endParaRPr lang="en-GB" sz="1000" dirty="0"/>
+          </a:p>
+          <a:p>
+            <a:pPr marL="0" indent="0">
+              <a:buNone/>
+            </a:pPr>
+            <a:r>
+              <a:rPr lang="en-GB" sz="1000" b="1" dirty="0">
+                <a:solidFill>
+                  <a:srgbClr val="000000"/>
+                </a:solidFill>
+                <a:latin typeface="+mn-lt"/>
+              </a:rPr>
+              <a:t>DR ARNE FLOH</a:t>
+            </a:r>
+          </a:p>
+          <a:p>
+            <a:pPr marL="0" indent="0">
+              <a:buNone/>
+            </a:pPr>
+            <a:r>
+              <a:rPr lang="en-GB" sz="1000" dirty="0">
+                <a:solidFill>
+                  <a:srgbClr val="000000"/>
+                </a:solidFill>
+                <a:latin typeface="+mn-lt"/>
+              </a:rPr>
+              <a:t>Senior Lecturer in Marketing</a:t>
+            </a:r>
+          </a:p>
+          <a:p>
+            <a:pPr marL="0" indent="0">
+              <a:buNone/>
+            </a:pPr>
+            <a:endParaRPr lang="en-GB" sz="1000" dirty="0"/>
+          </a:p>
+          <a:p>
+            <a:pPr marL="0" indent="0">
+              <a:buNone/>
+            </a:pPr>
+            <a:r>
+              <a:rPr lang="en-GB" sz="1000" dirty="0">
+                <a:solidFill>
+                  <a:srgbClr val="000000"/>
+                </a:solidFill>
+                <a:latin typeface="+mn-lt"/>
+              </a:rPr>
+              <a:t>F +43-31336-6367</a:t>
+            </a:r>
+          </a:p>
+          <a:p>
+            <a:pPr marL="0" indent="0">
+              <a:buNone/>
+            </a:pPr>
+            <a:r>
+              <a:rPr lang="en-GB" sz="1000" dirty="0">
+                <a:solidFill>
+                  <a:srgbClr val="000000"/>
+                </a:solidFill>
+                <a:latin typeface="+mn-lt"/>
+                <a:hlinkClick r:id="rId20"/>
+              </a:rPr>
+              <a:t>arne.floh@wu.ac.at</a:t>
+            </a:r>
+          </a:p>
+          <a:p>
+            <a:pPr marL="0" indent="0">
+              <a:buNone/>
+            </a:pPr>
+            <a:r>
+              <a:rPr lang="en-GB" sz="900" dirty="0">
+                <a:solidFill>
+                  <a:srgbClr val="000000"/>
+                </a:solidFill>
+                <a:latin typeface="+mn-lt"/>
+                <a:hlinkClick r:id="rId22"/>
+              </a:rPr>
+              <a:t>www.wu.ac.at/en/welthandel/arne-floh</a:t>
+            </a:r>
+          </a:p>
+          <a:p>
+            <a:pPr marL="0" indent="0">
+              <a:buNone/>
+            </a:pPr>
+            <a:r>
+              <a:rPr lang="en-GB" sz="1000" dirty="0">
+                <a:solidFill>
+                  <a:srgbClr val="000000"/>
+                </a:solidFill>
+                <a:latin typeface="+mn-lt"/>
+                <a:hlinkClick r:id="rId21"/>
+              </a:rPr>
+              <a:t>Office hours: book online</a:t>
+            </a:r>
           </a:p>
         </p:txBody>
       </p:sp>
@@ -7731,6 +8636,8 @@
     <p:sldLayoutId id="2147483667" r:id="rId13"/>
     <p:sldLayoutId id="2147483668" r:id="rId14"/>
     <p:sldLayoutId id="2147483670" r:id="rId15"/>
+    <p:sldLayoutId id="2147483692" r:id="rId19"/>
+    <p:sldLayoutId id="2147483695" r:id="rId20"/>
   </p:sldLayoutIdLst>
   <p:transition>
     <p:fade/>
@@ -8154,59 +9061,6 @@
       </p:sp>
       <p:sp>
         <p:nvSpPr>
-          <p:cNvPr id="7" name="Textplatzhalter 6"/>
-          <p:cNvSpPr>
-            <a:spLocks noGrp="1"/>
-          </p:cNvSpPr>
-          <p:nvPr>
-            <p:ph type="body" sz="quarter" idx="11"/>
-          </p:nvPr>
-        </p:nvSpPr>
-        <p:spPr>
-          <a:xfrm>
-            <a:off x="287338" y="2941638"/>
-            <a:ext cx="4284662" cy="1250000"/>
-          </a:xfrm>
-        </p:spPr>
-        <p:txBody>
-          <a:bodyPr/>
-          <a:lstStyle/>
-          <a:p>
-            <a:pPr lvl="0"/>
-            <a:r>
-              <a:rPr lang="en-GB" dirty="0" sz="1100"/>
-              <a:t>Dr Arne Floh, Senior Lecturer in Marketing</a:t>
-            </a:r>
-          </a:p>
-          <a:p>
-            <a:pPr lvl="0"/>
-            <a:r>
-              <a:rPr lang="en-GB" dirty="0" sz="1100"/>
-              <a:t>WU Vienna, Institute for International Business</a:t>
-            </a:r>
-          </a:p>
-          <a:p>
-            <a:pPr lvl="0"/>
-            <a:r>
-              <a:rPr lang="en-GB" dirty="0" sz="1100">
-                <a:hlinkClick r:id="rId20"/>
-              </a:rPr>
-              <a:t>arne.floh@wu.ac.at</a:t>
-            </a:r>
-          </a:p>
-          <a:p>
-            <a:pPr lvl="0"/>
-            <a:r>
-              <a:rPr lang="en-GB" dirty="0" sz="1100">
-                <a:hlinkClick r:id="rId21"/>
-              </a:rPr>
-              <a:t>Office hours: book online (Google Calendar)</a:t>
-            </a:r>
-          </a:p>
-        </p:txBody>
-      </p:sp>
-      <p:sp>
-        <p:nvSpPr>
           <p:cNvPr id="8" name="Textplatzhalter 7"/>
           <p:cNvSpPr>
             <a:spLocks noGrp="1"/>
@@ -8261,106 +9115,6 @@
           <a:chExt cx="0" cy="0"/>
         </a:xfrm>
       </p:grpSpPr>
-      <p:sp>
-        <p:nvSpPr>
-          <p:cNvPr id="8" name="Textplatzhalter 3"/>
-          <p:cNvSpPr txBox="1">
-            <a:spLocks noGrp="1"/>
-          </p:cNvSpPr>
-          <p:nvPr>
-            <p:ph type="body" sz="quarter" idx="10"/>
-          </p:nvPr>
-        </p:nvSpPr>
-        <p:spPr>
-          <a:xfrm>
-            <a:off x="1691680" y="2559843"/>
-            <a:ext cx="2756266" cy="1811291"/>
-          </a:xfrm>
-        </p:spPr>
-        <p:txBody>
-          <a:bodyPr>
-            <a:normAutofit fontScale="92500" lnSpcReduction="10000"/>
-          </a:bodyPr>
-          <a:lstStyle/>
-          <a:p>
-            <a:pPr lvl="0"/>
-            <a:r>
-              <a:rPr lang="en-GB" dirty="0" b="1"/>
-              <a:t>INSTITUTE FOR INTERNATIONAL BUSINESS</a:t>
-            </a:r>
-          </a:p>
-          <a:p>
-            <a:pPr lvl="0"/>
-            <a:r>
-              <a:rPr lang="en-GB" dirty="0"/>
-              <a:t>WU Vienna</a:t>
-            </a:r>
-          </a:p>
-          <a:p>
-            <a:pPr lvl="0"/>
-            <a:r>
-              <a:rPr lang="en-GB" dirty="0"/>
-              <a:t>Welthandelsplatz 1, 1020 Vienna, Austria</a:t>
-            </a:r>
-          </a:p>
-          <a:p>
-            <a:pPr lvl="0"/>
-            <a:r>
-              <a:rPr lang="en-GB" dirty="0"/>
-              <a:t/>
-            </a:r>
-          </a:p>
-          <a:p>
-            <a:pPr lvl="0"/>
-            <a:r>
-              <a:rPr lang="en-GB" dirty="0" b="1"/>
-              <a:t>DR ARNE FLOH</a:t>
-            </a:r>
-          </a:p>
-          <a:p>
-            <a:pPr lvl="0"/>
-            <a:r>
-              <a:rPr lang="en-GB" dirty="0"/>
-              <a:t>Senior Lecturer in Marketing</a:t>
-            </a:r>
-          </a:p>
-          <a:p>
-            <a:pPr lvl="0"/>
-            <a:r>
-              <a:rPr lang="en-GB" dirty="0"/>
-              <a:t/>
-            </a:r>
-          </a:p>
-          <a:p>
-            <a:pPr lvl="0"/>
-            <a:r>
-              <a:rPr lang="en-GB" dirty="0"/>
-              <a:t>F +43-31336-6367</a:t>
-            </a:r>
-          </a:p>
-          <a:p>
-            <a:pPr lvl="0"/>
-            <a:r>
-              <a:rPr lang="en-GB" dirty="0"/>
-              <a:t>arne.floh@wu.ac.at</a:t>
-            </a:r>
-          </a:p>
-          <a:p>
-            <a:pPr lvl="0"/>
-            <a:r>
-              <a:rPr lang="en-GB" dirty="0"/>
-              <a:t>www.wu.ac.at/en/welthandel/arne-floh</a:t>
-            </a:r>
-          </a:p>
-          <a:p>
-            <a:pPr lvl="0"/>
-            <a:r>
-              <a:rPr lang="en-GB" dirty="0"/>
-              <a:t>Office hours: by appointment</a:t>
-            </a:r>
-          </a:p>
-        </p:txBody>
-      </p:sp>
       <p:sp>
         <p:nvSpPr>
           <p:cNvPr id="7" name="Titel 6"/>

</xml_diff>